<commit_message>
build: reporte PDF (4 páginas, solo Arial) y diapositivas regenerados
</commit_message>
<xml_diff>
--- a/entregables/entrega_1/presentacion.pptx
+++ b/entregables/entrega_1/presentacion.pptx
@@ -3224,8 +3224,8 @@
         </p:blipFill>
         <p:spPr bwMode="auto">
           <a:xfrm>
-            <a:off x="457200" y="1714500"/>
-            <a:ext cx="8229600" cy="2349500"/>
+            <a:off x="457200" y="1638300"/>
+            <a:ext cx="8229600" cy="2489200"/>
           </a:xfrm>
           <a:prstGeom prst="rect">
             <a:avLst/>
@@ -3278,14 +3278,21 @@
             <a:pPr lvl="0"/>
             <a:r>
               <a:rPr/>
-              <a:t>AUC por indicador 0.496–0.514; sector R² mediano 0.525</a:t>
+              <a:t>AUC por indicador 0.496–0.514 (HT2 no concluyente, HT3 no apoyada)</a:t>
             </a:r>
           </a:p>
           <a:p>
             <a:pPr lvl="0"/>
             <a:r>
               <a:rPr/>
-              <a:t>Múltiplos revierten en solo 7 de 29 tickers</a:t>
+              <a:t>Sector R² mediano 0.525 (HP3 apoyada)</a:t>
+            </a:r>
+          </a:p>
+          <a:p>
+            <a:pPr lvl="0"/>
+            <a:r>
+              <a:rPr/>
+              <a:t>Múltiplos revierten en 7 de 29 (HF1) y 10 de 29 (HF2), no apoyadas</a:t>
             </a:r>
           </a:p>
         </p:txBody>
@@ -3362,7 +3369,7 @@
             <a:pPr lvl="0"/>
             <a:r>
               <a:rPr/>
-              <a:t>Diseño: GARCH-t con innovaciones t, línea base GBM con deriva, múltiplos como contexto</a:t>
+              <a:t>Diseño: GARCH-t con innovaciones t, línea base GBM con deriva (no calibrada, rival justo), múltiplos como contexto</a:t>
             </a:r>
           </a:p>
           <a:p>
@@ -3994,7 +4001,21 @@
             <a:pPr lvl="0"/>
             <a:r>
               <a:rPr/>
-              <a:t>ν mediano 4.15; GARCH-t gana en 28 de 34 series</a:t>
+              <a:t>ν mediano 4.15; GARCH-t gana en 28 de 34 series (HP0, HT4 apoyadas)</a:t>
+            </a:r>
+          </a:p>
+          <a:p>
+            <a:pPr lvl="0"/>
+            <a:r>
+              <a:rPr/>
+              <a:t>Caminata aleatoria: pasan 15 de 30 (HT0 no apoyada); P_GBM no calibrada</a:t>
+            </a:r>
+          </a:p>
+          <a:p>
+            <a:pPr lvl="0"/>
+            <a:r>
+              <a:rPr/>
+              <a:t>VaR: GARCH-t adecuado en 14 de 30 (HP1 no apoyada)</a:t>
             </a:r>
           </a:p>
         </p:txBody>

</xml_diff>

<commit_message>
build: mockup, reporte PDF (4 páginas, solo Arial) y diapositivas regenerados
</commit_message>
<xml_diff>
--- a/entregables/entrega_1/presentacion.pptx
+++ b/entregables/entrega_1/presentacion.pptx
@@ -3369,7 +3369,7 @@
             <a:pPr lvl="0"/>
             <a:r>
               <a:rPr/>
-              <a:t>Diseño: GARCH-t con innovaciones t, línea base GBM con deriva (no calibrada, rival justo), múltiplos como contexto</a:t>
+              <a:t>Diseño: GARCH-t con innovaciones t; rival del SVM: tasa de toque por decil de σ (GBM con deriva solo como referencia teórica, no calibrado); múltiplos como contexto</a:t>
             </a:r>
           </a:p>
           <a:p>
@@ -3680,7 +3680,7 @@
             <a:pPr lvl="0"/>
             <a:r>
               <a:rPr/>
-              <a:t>SVM lineal explicable, con línea base GBM y error histórico</a:t>
+              <a:t>SVM lineal explicable, frente a la tasa de toque por decil de σ (GBM como referencia) y con error histórico</a:t>
             </a:r>
           </a:p>
           <a:p>
@@ -3788,7 +3788,7 @@
             <a:pPr lvl="0"/>
             <a:r>
               <a:rPr/>
-              <a:t>Cuatro líneas base; IC bootstrap para declarar una hipótesis apoyada</a:t>
+              <a:t>Cuatro líneas base (decide HT1 la tasa de toque por decil de σ); IC bootstrap para declarar una hipótesis apoyada</a:t>
             </a:r>
           </a:p>
         </p:txBody>

</xml_diff>

<commit_message>
docs: entregables de la entrega 1
</commit_message>
<xml_diff>
--- a/entregables/entrega_1/presentacion.pptx
+++ b/entregables/entrega_1/presentacion.pptx
@@ -1,6 +1,6 @@
 
 <file path=ppt/presentation.xml><?xml version="1.0" encoding="utf-8"?>
-<p:presentation xmlns:a="http://schemas.openxmlformats.org/drawingml/2006/main" xmlns:p="http://schemas.openxmlformats.org/presentationml/2006/main" xmlns:r="http://schemas.openxmlformats.org/officeDocument/2006/relationships" autoCompressPictures="0" saveSubsetFonts="1">
+<p:presentation xmlns:a="http://schemas.openxmlformats.org/drawingml/2006/main" xmlns:r="http://schemas.openxmlformats.org/officeDocument/2006/relationships" xmlns:p="http://schemas.openxmlformats.org/presentationml/2006/main" saveSubsetFonts="1" autoCompressPictures="0">
   <p:sldMasterIdLst>
     <p:sldMasterId id="2147483648" r:id="rId1"/>
   </p:sldMasterIdLst>
@@ -17,6 +17,8 @@
     <p:sldId id="265" r:id="rId11"/>
     <p:sldId id="266" r:id="rId12"/>
     <p:sldId id="267" r:id="rId13"/>
+    <p:sldId id="268" r:id="rId14"/>
+    <p:sldId id="269" r:id="rId15"/>
   </p:sldIdLst>
   <p:sldSz cx="9144000" cy="5143500" type="screen16x9"/>
   <p:notesSz cx="6858000" cy="9144000"/>
@@ -24,8 +26,8 @@
     <a:defPPr>
       <a:defRPr lang="en-US"/>
     </a:defPPr>
-    <a:lvl1pPr algn="l" defTabSz="457200" eaLnBrk="1" hangingPunct="1" latinLnBrk="0" marL="0" rtl="0">
-      <a:defRPr kern="1200" sz="1800">
+    <a:lvl1pPr marL="0" algn="l" defTabSz="457200" rtl="0" eaLnBrk="1" latinLnBrk="0" hangingPunct="1">
+      <a:defRPr sz="1800" kern="1200">
         <a:solidFill>
           <a:schemeClr val="tx1"/>
         </a:solidFill>
@@ -34,8 +36,8 @@
         <a:cs typeface="+mn-cs"/>
       </a:defRPr>
     </a:lvl1pPr>
-    <a:lvl2pPr algn="l" defTabSz="457200" eaLnBrk="1" hangingPunct="1" latinLnBrk="0" marL="457200" rtl="0">
-      <a:defRPr kern="1200" sz="1800">
+    <a:lvl2pPr marL="457200" algn="l" defTabSz="457200" rtl="0" eaLnBrk="1" latinLnBrk="0" hangingPunct="1">
+      <a:defRPr sz="1800" kern="1200">
         <a:solidFill>
           <a:schemeClr val="tx1"/>
         </a:solidFill>
@@ -44,8 +46,8 @@
         <a:cs typeface="+mn-cs"/>
       </a:defRPr>
     </a:lvl2pPr>
-    <a:lvl3pPr algn="l" defTabSz="457200" eaLnBrk="1" hangingPunct="1" latinLnBrk="0" marL="914400" rtl="0">
-      <a:defRPr kern="1200" sz="1800">
+    <a:lvl3pPr marL="914400" algn="l" defTabSz="457200" rtl="0" eaLnBrk="1" latinLnBrk="0" hangingPunct="1">
+      <a:defRPr sz="1800" kern="1200">
         <a:solidFill>
           <a:schemeClr val="tx1"/>
         </a:solidFill>
@@ -54,8 +56,8 @@
         <a:cs typeface="+mn-cs"/>
       </a:defRPr>
     </a:lvl3pPr>
-    <a:lvl4pPr algn="l" defTabSz="457200" eaLnBrk="1" hangingPunct="1" latinLnBrk="0" marL="1371600" rtl="0">
-      <a:defRPr kern="1200" sz="1800">
+    <a:lvl4pPr marL="1371600" algn="l" defTabSz="457200" rtl="0" eaLnBrk="1" latinLnBrk="0" hangingPunct="1">
+      <a:defRPr sz="1800" kern="1200">
         <a:solidFill>
           <a:schemeClr val="tx1"/>
         </a:solidFill>
@@ -64,8 +66,8 @@
         <a:cs typeface="+mn-cs"/>
       </a:defRPr>
     </a:lvl4pPr>
-    <a:lvl5pPr algn="l" defTabSz="457200" eaLnBrk="1" hangingPunct="1" latinLnBrk="0" marL="1828800" rtl="0">
-      <a:defRPr kern="1200" sz="1800">
+    <a:lvl5pPr marL="1828800" algn="l" defTabSz="457200" rtl="0" eaLnBrk="1" latinLnBrk="0" hangingPunct="1">
+      <a:defRPr sz="1800" kern="1200">
         <a:solidFill>
           <a:schemeClr val="tx1"/>
         </a:solidFill>
@@ -74,8 +76,8 @@
         <a:cs typeface="+mn-cs"/>
       </a:defRPr>
     </a:lvl5pPr>
-    <a:lvl6pPr algn="l" defTabSz="457200" eaLnBrk="1" hangingPunct="1" latinLnBrk="0" marL="2286000" rtl="0">
-      <a:defRPr kern="1200" sz="1800">
+    <a:lvl6pPr marL="2286000" algn="l" defTabSz="457200" rtl="0" eaLnBrk="1" latinLnBrk="0" hangingPunct="1">
+      <a:defRPr sz="1800" kern="1200">
         <a:solidFill>
           <a:schemeClr val="tx1"/>
         </a:solidFill>
@@ -84,8 +86,8 @@
         <a:cs typeface="+mn-cs"/>
       </a:defRPr>
     </a:lvl6pPr>
-    <a:lvl7pPr algn="l" defTabSz="457200" eaLnBrk="1" hangingPunct="1" latinLnBrk="0" marL="2743200" rtl="0">
-      <a:defRPr kern="1200" sz="1800">
+    <a:lvl7pPr marL="2743200" algn="l" defTabSz="457200" rtl="0" eaLnBrk="1" latinLnBrk="0" hangingPunct="1">
+      <a:defRPr sz="1800" kern="1200">
         <a:solidFill>
           <a:schemeClr val="tx1"/>
         </a:solidFill>
@@ -94,8 +96,8 @@
         <a:cs typeface="+mn-cs"/>
       </a:defRPr>
     </a:lvl7pPr>
-    <a:lvl8pPr algn="l" defTabSz="457200" eaLnBrk="1" hangingPunct="1" latinLnBrk="0" marL="3200400" rtl="0">
-      <a:defRPr kern="1200" sz="1800">
+    <a:lvl8pPr marL="3200400" algn="l" defTabSz="457200" rtl="0" eaLnBrk="1" latinLnBrk="0" hangingPunct="1">
+      <a:defRPr sz="1800" kern="1200">
         <a:solidFill>
           <a:schemeClr val="tx1"/>
         </a:solidFill>
@@ -104,8 +106,8 @@
         <a:cs typeface="+mn-cs"/>
       </a:defRPr>
     </a:lvl8pPr>
-    <a:lvl9pPr algn="l" defTabSz="457200" eaLnBrk="1" hangingPunct="1" latinLnBrk="0" marL="3657600" rtl="0">
-      <a:defRPr kern="1200" sz="1800">
+    <a:lvl9pPr marL="3657600" algn="l" defTabSz="457200" rtl="0" eaLnBrk="1" latinLnBrk="0" hangingPunct="1">
+      <a:defRPr sz="1800" kern="1200">
         <a:solidFill>
           <a:schemeClr val="tx1"/>
         </a:solidFill>
@@ -2577,7 +2579,7 @@
 </file>
 
 <file path=ppt/slideMasters/slideMaster1.xml><?xml version="1.0" encoding="utf-8"?>
-<p:sldMaster xmlns:a="http://schemas.openxmlformats.org/drawingml/2006/main" xmlns:p="http://schemas.openxmlformats.org/presentationml/2006/main" xmlns:r="http://schemas.openxmlformats.org/officeDocument/2006/relationships">
+<p:sldMaster xmlns:a="http://schemas.openxmlformats.org/drawingml/2006/main" xmlns:r="http://schemas.openxmlformats.org/officeDocument/2006/relationships" xmlns:p="http://schemas.openxmlformats.org/presentationml/2006/main">
   <p:cSld>
     <p:bg>
       <p:bgRef idx="1001">
@@ -2618,7 +2620,7 @@
           </a:prstGeom>
         </p:spPr>
         <p:txBody>
-          <a:bodyPr anchor="ctr" bIns="45720" lIns="91440" rIns="91440" rtlCol="0" tIns="45720" vert="horz">
+          <a:bodyPr vert="horz" lIns="91440" tIns="45720" rIns="91440" bIns="45720" rtlCol="0" anchor="ctr">
             <a:normAutofit/>
           </a:bodyPr>
           <a:lstStyle/>
@@ -2637,7 +2639,7 @@
             <a:spLocks noGrp="1"/>
           </p:cNvSpPr>
           <p:nvPr>
-            <p:ph idx="1" type="body"/>
+            <p:ph type="body" idx="1"/>
           </p:nvPr>
         </p:nvSpPr>
         <p:spPr>
@@ -2650,7 +2652,7 @@
           </a:prstGeom>
         </p:spPr>
         <p:txBody>
-          <a:bodyPr bIns="45720" lIns="91440" rIns="91440" rtlCol="0" tIns="45720" vert="horz">
+          <a:bodyPr vert="horz" lIns="91440" tIns="45720" rIns="91440" bIns="45720" rtlCol="0">
             <a:normAutofit/>
           </a:bodyPr>
           <a:lstStyle/>
@@ -2698,7 +2700,7 @@
             <a:spLocks noGrp="1"/>
           </p:cNvSpPr>
           <p:nvPr>
-            <p:ph idx="2" sz="half" type="dt"/>
+            <p:ph type="dt" sz="half" idx="2"/>
           </p:nvPr>
         </p:nvSpPr>
         <p:spPr>
@@ -2711,7 +2713,7 @@
           </a:prstGeom>
         </p:spPr>
         <p:txBody>
-          <a:bodyPr anchor="ctr" bIns="45720" lIns="91440" rIns="91440" rtlCol="0" tIns="45720" vert="horz"/>
+          <a:bodyPr vert="horz" lIns="91440" tIns="45720" rIns="91440" bIns="45720" rtlCol="0" anchor="ctr"/>
           <a:lstStyle>
             <a:lvl1pPr algn="l">
               <a:defRPr sz="900">
@@ -2739,7 +2741,7 @@
             <a:spLocks noGrp="1"/>
           </p:cNvSpPr>
           <p:nvPr>
-            <p:ph idx="3" sz="quarter" type="ftr"/>
+            <p:ph type="ftr" sz="quarter" idx="3"/>
           </p:nvPr>
         </p:nvSpPr>
         <p:spPr>
@@ -2752,7 +2754,7 @@
           </a:prstGeom>
         </p:spPr>
         <p:txBody>
-          <a:bodyPr anchor="ctr" bIns="45720" lIns="91440" rIns="91440" rtlCol="0" tIns="45720" vert="horz"/>
+          <a:bodyPr vert="horz" lIns="91440" tIns="45720" rIns="91440" bIns="45720" rtlCol="0" anchor="ctr"/>
           <a:lstStyle>
             <a:lvl1pPr algn="ctr">
               <a:defRPr sz="900">
@@ -2776,7 +2778,7 @@
             <a:spLocks noGrp="1"/>
           </p:cNvSpPr>
           <p:nvPr>
-            <p:ph idx="4" sz="quarter" type="sldNum"/>
+            <p:ph type="sldNum" sz="quarter" idx="4"/>
           </p:nvPr>
         </p:nvSpPr>
         <p:spPr>
@@ -2789,7 +2791,7 @@
           </a:prstGeom>
         </p:spPr>
         <p:txBody>
-          <a:bodyPr anchor="ctr" bIns="45720" lIns="91440" rIns="91440" rtlCol="0" tIns="45720" vert="horz"/>
+          <a:bodyPr vert="horz" lIns="91440" tIns="45720" rIns="91440" bIns="45720" rtlCol="0" anchor="ctr"/>
           <a:lstStyle>
             <a:lvl1pPr algn="r">
               <a:defRPr sz="900">
@@ -2817,7 +2819,7 @@
       </p:ext>
     </p:extLst>
   </p:cSld>
-  <p:clrMap accent1="accent1" accent2="accent2" accent3="accent3" accent4="accent4" accent5="accent5" accent6="accent6" bg1="lt1" bg2="lt2" folHlink="folHlink" hlink="hlink" tx1="dk1" tx2="dk2"/>
+  <p:clrMap bg1="lt1" tx1="dk1" bg2="lt2" tx2="dk2" accent1="accent1" accent2="accent2" accent3="accent3" accent4="accent4" accent5="accent5" accent6="accent6" hlink="hlink" folHlink="folHlink"/>
   <p:sldLayoutIdLst>
     <p:sldLayoutId id="2147483649" r:id="rId1"/>
     <p:sldLayoutId id="2147483650" r:id="rId2"/>
@@ -2833,12 +2835,12 @@
   </p:sldLayoutIdLst>
   <p:txStyles>
     <p:titleStyle>
-      <a:lvl1pPr algn="ctr" defTabSz="342900" eaLnBrk="1" hangingPunct="1" latinLnBrk="0" rtl="0">
+      <a:lvl1pPr algn="ctr" defTabSz="342900" rtl="0" eaLnBrk="1" latinLnBrk="0" hangingPunct="1">
         <a:spcBef>
           <a:spcPct val="0"/>
         </a:spcBef>
         <a:buNone/>
-        <a:defRPr kern="1200" sz="3300">
+        <a:defRPr sz="3300" kern="1200">
           <a:solidFill>
             <a:schemeClr val="tx1"/>
           </a:solidFill>
@@ -2849,13 +2851,13 @@
       </a:lvl1pPr>
     </p:titleStyle>
     <p:bodyStyle>
-      <a:lvl1pPr algn="l" defTabSz="342900" eaLnBrk="1" hangingPunct="1" indent="-342900" latinLnBrk="0" marL="342900" rtl="0">
+      <a:lvl1pPr marL="342900" indent="-342900" algn="l" defTabSz="342900" rtl="0" eaLnBrk="1" latinLnBrk="0" hangingPunct="1">
         <a:spcBef>
           <a:spcPct val="20000"/>
         </a:spcBef>
         <a:buFont typeface="Arial"/>
         <a:buChar char="•"/>
-        <a:defRPr kern="1200" sz="2400">
+        <a:defRPr sz="2400" kern="1200">
           <a:solidFill>
             <a:schemeClr val="tx1"/>
           </a:solidFill>
@@ -2864,13 +2866,13 @@
           <a:cs typeface="+mn-cs"/>
         </a:defRPr>
       </a:lvl1pPr>
-      <a:lvl2pPr algn="l" defTabSz="342900" eaLnBrk="1" hangingPunct="1" indent="-342900" latinLnBrk="0" marL="685800" rtl="0">
+      <a:lvl2pPr marL="685800" indent="-342900" algn="l" defTabSz="342900" rtl="0" eaLnBrk="1" latinLnBrk="0" hangingPunct="1">
         <a:spcBef>
           <a:spcPct val="20000"/>
         </a:spcBef>
         <a:buFont typeface="Arial"/>
         <a:buChar char="–"/>
-        <a:defRPr kern="1200" sz="2100">
+        <a:defRPr sz="2100" kern="1200">
           <a:solidFill>
             <a:schemeClr val="tx1"/>
           </a:solidFill>
@@ -2879,13 +2881,13 @@
           <a:cs typeface="+mn-cs"/>
         </a:defRPr>
       </a:lvl2pPr>
-      <a:lvl3pPr algn="l" defTabSz="342900" eaLnBrk="1" hangingPunct="1" indent="-342900" latinLnBrk="0" marL="1028700" rtl="0">
+      <a:lvl3pPr marL="1028700" indent="-342900" algn="l" defTabSz="342900" rtl="0" eaLnBrk="1" latinLnBrk="0" hangingPunct="1">
         <a:spcBef>
           <a:spcPct val="20000"/>
         </a:spcBef>
         <a:buFont typeface="Arial"/>
         <a:buChar char="•"/>
-        <a:defRPr kern="1200" sz="1800">
+        <a:defRPr sz="1800" kern="1200">
           <a:solidFill>
             <a:schemeClr val="tx1"/>
           </a:solidFill>
@@ -2894,13 +2896,13 @@
           <a:cs typeface="+mn-cs"/>
         </a:defRPr>
       </a:lvl3pPr>
-      <a:lvl4pPr algn="l" defTabSz="342900" eaLnBrk="1" hangingPunct="1" indent="-342900" latinLnBrk="0" marL="1371600" rtl="0">
+      <a:lvl4pPr marL="1371600" indent="-342900" algn="l" defTabSz="342900" rtl="0" eaLnBrk="1" latinLnBrk="0" hangingPunct="1">
         <a:spcBef>
           <a:spcPct val="20000"/>
         </a:spcBef>
         <a:buFont typeface="Arial"/>
         <a:buChar char="–"/>
-        <a:defRPr kern="1200" sz="1500">
+        <a:defRPr sz="1500" kern="1200">
           <a:solidFill>
             <a:schemeClr val="tx1"/>
           </a:solidFill>
@@ -2909,13 +2911,13 @@
           <a:cs typeface="+mn-cs"/>
         </a:defRPr>
       </a:lvl4pPr>
-      <a:lvl5pPr algn="l" defTabSz="342900" eaLnBrk="1" hangingPunct="1" indent="-342900" latinLnBrk="0" marL="1714500" rtl="0">
+      <a:lvl5pPr marL="1714500" indent="-342900" algn="l" defTabSz="342900" rtl="0" eaLnBrk="1" latinLnBrk="0" hangingPunct="1">
         <a:spcBef>
           <a:spcPct val="20000"/>
         </a:spcBef>
         <a:buFont typeface="Arial"/>
         <a:buChar char="»"/>
-        <a:defRPr kern="1200" sz="1500">
+        <a:defRPr sz="1500" kern="1200">
           <a:solidFill>
             <a:schemeClr val="tx1"/>
           </a:solidFill>
@@ -2924,13 +2926,13 @@
           <a:cs typeface="+mn-cs"/>
         </a:defRPr>
       </a:lvl5pPr>
-      <a:lvl6pPr algn="l" defTabSz="342900" eaLnBrk="1" hangingPunct="1" indent="-342900" latinLnBrk="0" marL="2057400" rtl="0">
+      <a:lvl6pPr marL="2057400" indent="-342900" algn="l" defTabSz="342900" rtl="0" eaLnBrk="1" latinLnBrk="0" hangingPunct="1">
         <a:spcBef>
           <a:spcPct val="20000"/>
         </a:spcBef>
         <a:buFont typeface="Arial"/>
         <a:buChar char="•"/>
-        <a:defRPr kern="1200" sz="1500">
+        <a:defRPr sz="1500" kern="1200">
           <a:solidFill>
             <a:schemeClr val="tx1"/>
           </a:solidFill>
@@ -2939,13 +2941,13 @@
           <a:cs typeface="+mn-cs"/>
         </a:defRPr>
       </a:lvl6pPr>
-      <a:lvl7pPr algn="l" defTabSz="342900" eaLnBrk="1" hangingPunct="1" indent="-342900" latinLnBrk="0" marL="2400300" rtl="0">
+      <a:lvl7pPr marL="2400300" indent="-342900" algn="l" defTabSz="342900" rtl="0" eaLnBrk="1" latinLnBrk="0" hangingPunct="1">
         <a:spcBef>
           <a:spcPct val="20000"/>
         </a:spcBef>
         <a:buFont typeface="Arial"/>
         <a:buChar char="•"/>
-        <a:defRPr kern="1200" sz="1500">
+        <a:defRPr sz="1500" kern="1200">
           <a:solidFill>
             <a:schemeClr val="tx1"/>
           </a:solidFill>
@@ -2954,13 +2956,13 @@
           <a:cs typeface="+mn-cs"/>
         </a:defRPr>
       </a:lvl7pPr>
-      <a:lvl8pPr algn="l" defTabSz="342900" eaLnBrk="1" hangingPunct="1" indent="-342900" latinLnBrk="0" marL="2743200" rtl="0">
+      <a:lvl8pPr marL="2743200" indent="-342900" algn="l" defTabSz="342900" rtl="0" eaLnBrk="1" latinLnBrk="0" hangingPunct="1">
         <a:spcBef>
           <a:spcPct val="20000"/>
         </a:spcBef>
         <a:buFont typeface="Arial"/>
         <a:buChar char="•"/>
-        <a:defRPr kern="1200" sz="1500">
+        <a:defRPr sz="1500" kern="1200">
           <a:solidFill>
             <a:schemeClr val="tx1"/>
           </a:solidFill>
@@ -2969,13 +2971,13 @@
           <a:cs typeface="+mn-cs"/>
         </a:defRPr>
       </a:lvl8pPr>
-      <a:lvl9pPr algn="l" defTabSz="342900" eaLnBrk="1" hangingPunct="1" indent="-342900" latinLnBrk="0" marL="3086100" rtl="0">
+      <a:lvl9pPr marL="3086100" indent="-342900" algn="l" defTabSz="342900" rtl="0" eaLnBrk="1" latinLnBrk="0" hangingPunct="1">
         <a:spcBef>
           <a:spcPct val="20000"/>
         </a:spcBef>
         <a:buFont typeface="Arial"/>
         <a:buChar char="•"/>
-        <a:defRPr kern="1200" sz="1500">
+        <a:defRPr sz="1500" kern="1200">
           <a:solidFill>
             <a:schemeClr val="tx1"/>
           </a:solidFill>
@@ -2989,8 +2991,8 @@
       <a:defPPr>
         <a:defRPr lang="en-US"/>
       </a:defPPr>
-      <a:lvl1pPr algn="l" defTabSz="342900" eaLnBrk="1" hangingPunct="1" latinLnBrk="0" marL="0" rtl="0">
-        <a:defRPr kern="1200" sz="1350">
+      <a:lvl1pPr marL="0" algn="l" defTabSz="342900" rtl="0" eaLnBrk="1" latinLnBrk="0" hangingPunct="1">
+        <a:defRPr sz="1350" kern="1200">
           <a:solidFill>
             <a:schemeClr val="tx1"/>
           </a:solidFill>
@@ -2999,8 +3001,8 @@
           <a:cs typeface="+mn-cs"/>
         </a:defRPr>
       </a:lvl1pPr>
-      <a:lvl2pPr algn="l" defTabSz="342900" eaLnBrk="1" hangingPunct="1" latinLnBrk="0" marL="342900" rtl="0">
-        <a:defRPr kern="1200" sz="1350">
+      <a:lvl2pPr marL="342900" algn="l" defTabSz="342900" rtl="0" eaLnBrk="1" latinLnBrk="0" hangingPunct="1">
+        <a:defRPr sz="1350" kern="1200">
           <a:solidFill>
             <a:schemeClr val="tx1"/>
           </a:solidFill>
@@ -3009,8 +3011,8 @@
           <a:cs typeface="+mn-cs"/>
         </a:defRPr>
       </a:lvl2pPr>
-      <a:lvl3pPr algn="l" defTabSz="342900" eaLnBrk="1" hangingPunct="1" latinLnBrk="0" marL="685800" rtl="0">
-        <a:defRPr kern="1200" sz="1350">
+      <a:lvl3pPr marL="685800" algn="l" defTabSz="342900" rtl="0" eaLnBrk="1" latinLnBrk="0" hangingPunct="1">
+        <a:defRPr sz="1350" kern="1200">
           <a:solidFill>
             <a:schemeClr val="tx1"/>
           </a:solidFill>
@@ -3019,8 +3021,8 @@
           <a:cs typeface="+mn-cs"/>
         </a:defRPr>
       </a:lvl3pPr>
-      <a:lvl4pPr algn="l" defTabSz="342900" eaLnBrk="1" hangingPunct="1" latinLnBrk="0" marL="1028700" rtl="0">
-        <a:defRPr kern="1200" sz="1350">
+      <a:lvl4pPr marL="1028700" algn="l" defTabSz="342900" rtl="0" eaLnBrk="1" latinLnBrk="0" hangingPunct="1">
+        <a:defRPr sz="1350" kern="1200">
           <a:solidFill>
             <a:schemeClr val="tx1"/>
           </a:solidFill>
@@ -3029,8 +3031,8 @@
           <a:cs typeface="+mn-cs"/>
         </a:defRPr>
       </a:lvl4pPr>
-      <a:lvl5pPr algn="l" defTabSz="342900" eaLnBrk="1" hangingPunct="1" latinLnBrk="0" marL="1371600" rtl="0">
-        <a:defRPr kern="1200" sz="1350">
+      <a:lvl5pPr marL="1371600" algn="l" defTabSz="342900" rtl="0" eaLnBrk="1" latinLnBrk="0" hangingPunct="1">
+        <a:defRPr sz="1350" kern="1200">
           <a:solidFill>
             <a:schemeClr val="tx1"/>
           </a:solidFill>
@@ -3039,8 +3041,8 @@
           <a:cs typeface="+mn-cs"/>
         </a:defRPr>
       </a:lvl5pPr>
-      <a:lvl6pPr algn="l" defTabSz="342900" eaLnBrk="1" hangingPunct="1" latinLnBrk="0" marL="1714500" rtl="0">
-        <a:defRPr kern="1200" sz="1350">
+      <a:lvl6pPr marL="1714500" algn="l" defTabSz="342900" rtl="0" eaLnBrk="1" latinLnBrk="0" hangingPunct="1">
+        <a:defRPr sz="1350" kern="1200">
           <a:solidFill>
             <a:schemeClr val="tx1"/>
           </a:solidFill>
@@ -3049,8 +3051,8 @@
           <a:cs typeface="+mn-cs"/>
         </a:defRPr>
       </a:lvl6pPr>
-      <a:lvl7pPr algn="l" defTabSz="342900" eaLnBrk="1" hangingPunct="1" latinLnBrk="0" marL="2057400" rtl="0">
-        <a:defRPr kern="1200" sz="1350">
+      <a:lvl7pPr marL="2057400" algn="l" defTabSz="342900" rtl="0" eaLnBrk="1" latinLnBrk="0" hangingPunct="1">
+        <a:defRPr sz="1350" kern="1200">
           <a:solidFill>
             <a:schemeClr val="tx1"/>
           </a:solidFill>
@@ -3059,8 +3061,8 @@
           <a:cs typeface="+mn-cs"/>
         </a:defRPr>
       </a:lvl7pPr>
-      <a:lvl8pPr algn="l" defTabSz="342900" eaLnBrk="1" hangingPunct="1" latinLnBrk="0" marL="2400300" rtl="0">
-        <a:defRPr kern="1200" sz="1350">
+      <a:lvl8pPr marL="2400300" algn="l" defTabSz="342900" rtl="0" eaLnBrk="1" latinLnBrk="0" hangingPunct="1">
+        <a:defRPr sz="1350" kern="1200">
           <a:solidFill>
             <a:schemeClr val="tx1"/>
           </a:solidFill>
@@ -3069,8 +3071,8 @@
           <a:cs typeface="+mn-cs"/>
         </a:defRPr>
       </a:lvl8pPr>
-      <a:lvl9pPr algn="l" defTabSz="342900" eaLnBrk="1" hangingPunct="1" latinLnBrk="0" marL="2743200" rtl="0">
-        <a:defRPr kern="1200" sz="1350">
+      <a:lvl9pPr marL="2743200" algn="l" defTabSz="342900" rtl="0" eaLnBrk="1" latinLnBrk="0" hangingPunct="1">
+        <a:defRPr sz="1350" kern="1200">
           <a:solidFill>
             <a:schemeClr val="tx1"/>
           </a:solidFill>
@@ -3126,7 +3128,7 @@
             </a:pPr>
             <a:r>
               <a:rPr/>
-              <a:t>Asistente Bursátil para el inversor value colombiano</a:t>
+              <a:t>Asistente bursátil para el inversor value colombiano</a:t>
             </a:r>
           </a:p>
         </p:txBody>
@@ -3138,7 +3140,7 @@
             <a:spLocks noGrp="1"/>
           </p:cNvSpPr>
           <p:nvPr>
-            <p:ph idx="1" type="subTitle"/>
+            <p:ph type="subTitle" idx="1"/>
           </p:nvPr>
         </p:nvSpPr>
         <p:spPr>
@@ -3156,7 +3158,38 @@
             </a:pPr>
             <a:r>
               <a:rPr/>
-              <a:t>Louis Gualtero · MINE-4101 · Entrega 1</a:t>
+              <a:t>Entrega 1 · MINE-4101 Ciencia de Datos Aplicada · Universidad de los Andes</a:t>
+            </a:r>
+            <a:br/>
+            <a:br/>
+            <a:r>
+              <a:rPr/>
+              <a:t>Louis Gualtero · trabajo individual autorizado por el profesor</a:t>
+            </a:r>
+          </a:p>
+        </p:txBody>
+      </p:sp>
+      <p:sp>
+        <p:nvSpPr>
+          <p:cNvPr id="4" name="Date Placeholder 3"/>
+          <p:cNvSpPr>
+            <a:spLocks noGrp="1"/>
+          </p:cNvSpPr>
+          <p:nvPr>
+            <p:ph type="dt" sz="half" idx="10"/>
+          </p:nvPr>
+        </p:nvSpPr>
+        <p:spPr/>
+        <p:txBody>
+          <a:bodyPr/>
+          <a:lstStyle/>
+          <a:p>
+            <a:pPr lvl="0" indent="0" marL="0">
+              <a:buNone/>
+            </a:pPr>
+            <a:r>
+              <a:rPr/>
+              <a:t>Octubre 2026</a:t>
             </a:r>
           </a:p>
         </p:txBody>
@@ -3203,14 +3236,14 @@
             </a:pPr>
             <a:r>
               <a:rPr/>
-              <a:t>6. EDA: señal débil, sector fuerte</a:t>
+              <a:t>8. P2: barato sube más, descomposición compatible con trampa de valor</a:t>
             </a:r>
           </a:p>
         </p:txBody>
       </p:sp>
       <p:pic>
         <p:nvPicPr>
-          <p:cNvPr descr="assets/nb04_auc_por_regimen.png" id="0" name="Picture 1"/>
+          <p:cNvPr descr="assets/nb04_p2_descomposicion.png" id="0" name="Picture 1"/>
           <p:cNvPicPr>
             <a:picLocks noGrp="1" noChangeAspect="1"/>
           </p:cNvPicPr>
@@ -3224,8 +3257,8 @@
         </p:blipFill>
         <p:spPr bwMode="auto">
           <a:xfrm>
-            <a:off x="457200" y="1638300"/>
-            <a:ext cx="8229600" cy="2489200"/>
+            <a:off x="1562100" y="1193800"/>
+            <a:ext cx="6032500" cy="3390900"/>
           </a:xfrm>
           <a:prstGeom prst="rect">
             <a:avLst/>
@@ -3275,24 +3308,20 @@
           <a:bodyPr/>
           <a:lstStyle/>
           <a:p>
-            <a:pPr lvl="0"/>
+            <a:pPr lvl="0" indent="0" marL="0">
+              <a:buNone/>
+            </a:pPr>
             <a:r>
               <a:rPr/>
-              <a:t>AUC por indicador 0.496–0.514 (HT2 no concluyente, HT3 no apoyada)</a:t>
-            </a:r>
-          </a:p>
-          <a:p>
-            <a:pPr lvl="0"/>
+              <a:t>Barato − caro: </a:t>
+            </a:r>
+            <a:r>
+              <a:rPr b="1"/>
+              <a:t>+0,153 anualizado en log</a:t>
+            </a:r>
             <a:r>
               <a:rPr/>
-              <a:t>Sector R² mediano 0.525 (HP3 apoyada)</a:t>
-            </a:r>
-          </a:p>
-          <a:p>
-            <a:pPr lvl="0"/>
-            <a:r>
-              <a:rPr/>
-              <a:t>Múltiplos revierten en 7 de 29 (HF1) y 10 de 29 (HF2), no apoyadas</a:t>
+              <a:t> (IC95 por empresa [+0,091; +0,221]). Precio aporta +0,15 (IC excluye 0); EPS promedio −0,15 (IC cruza 0). nb04 §2.7–§2.8.</a:t>
             </a:r>
           </a:p>
         </p:txBody>
@@ -3339,11 +3368,63 @@
             </a:pPr>
             <a:r>
               <a:rPr/>
-              <a:t>7. Conclusiones y próximos pasos</a:t>
-            </a:r>
-          </a:p>
-        </p:txBody>
-      </p:sp>
+              <a:t>9. P4: ningún indicador supera la línea base por decil de σ</a:t>
+            </a:r>
+          </a:p>
+        </p:txBody>
+      </p:sp>
+      <p:pic>
+        <p:nvPicPr>
+          <p:cNvPr descr="assets/nb04_p4_zonas.png" id="0" name="Picture 1"/>
+          <p:cNvPicPr>
+            <a:picLocks noGrp="1" noChangeAspect="1"/>
+          </p:cNvPicPr>
+          <p:nvPr/>
+        </p:nvPicPr>
+        <p:blipFill>
+          <a:blip r:embed="rId2"/>
+          <a:stretch>
+            <a:fillRect/>
+          </a:stretch>
+        </p:blipFill>
+        <p:spPr bwMode="auto">
+          <a:xfrm>
+            <a:off x="508000" y="1193800"/>
+            <a:ext cx="8140700" cy="3390900"/>
+          </a:xfrm>
+          <a:prstGeom prst="rect">
+            <a:avLst/>
+          </a:prstGeom>
+          <a:noFill/>
+          <a:ln w="9525">
+            <a:noFill/>
+            <a:headEnd/>
+            <a:tailEnd/>
+          </a:ln>
+        </p:spPr>
+      </p:pic>
+    </p:spTree>
+  </p:cSld>
+</p:sld>
+</file>
+
+<file path=ppt/slides/slide13.xml><?xml version="1.0" encoding="utf-8"?>
+<p:sld xmlns:a="http://schemas.openxmlformats.org/drawingml/2006/main" xmlns:r="http://schemas.openxmlformats.org/officeDocument/2006/relationships" xmlns:p="http://schemas.openxmlformats.org/presentationml/2006/main">
+  <p:cSld>
+    <p:spTree>
+      <p:nvGrpSpPr>
+        <p:cNvPr id="1" name=""/>
+        <p:cNvGrpSpPr/>
+        <p:nvPr/>
+      </p:nvGrpSpPr>
+      <p:grpSpPr>
+        <a:xfrm>
+          <a:off x="0" y="0"/>
+          <a:ext cx="0" cy="0"/>
+          <a:chOff x="0" y="0"/>
+          <a:chExt cx="0" cy="0"/>
+        </a:xfrm>
+      </p:grpSpPr>
       <p:sp>
         <p:nvSpPr>
           <p:cNvPr id="3" name="Content Placeholder 2"/>
@@ -3359,31 +3440,151 @@
           <a:bodyPr/>
           <a:lstStyle/>
           <a:p>
+            <a:pPr lvl="0" indent="0" marL="0">
+              <a:buNone/>
+            </a:pPr>
+            <a:r>
+              <a:rPr/>
+              <a:t>7 IC95 (Bonferroni ≈ 99,3 %) cruzan 0; AUC base </a:t>
+            </a:r>
+            <a:r>
+              <a:rPr b="1"/>
+              <a:t>0,591</a:t>
+            </a:r>
+            <a:r>
+              <a:rPr/>
+              <a:t> con N = 60. Consecuencia: </a:t>
+            </a:r>
+            <a:r>
+              <a:rPr>
+                <a:latin typeface="Courier"/>
+              </a:rPr>
+              <a:t>variables_svm = {|r_t|, σ20/σ252, σ252}</a:t>
+            </a:r>
+            <a:r>
+              <a:rPr/>
+              <a:t>. nb04 §5.3.</a:t>
+            </a:r>
+          </a:p>
+        </p:txBody>
+      </p:sp>
+    </p:spTree>
+  </p:cSld>
+</p:sld>
+</file>
+
+<file path=ppt/slides/slide14.xml><?xml version="1.0" encoding="utf-8"?>
+<p:sld xmlns:a="http://schemas.openxmlformats.org/drawingml/2006/main" xmlns:r="http://schemas.openxmlformats.org/officeDocument/2006/relationships" xmlns:p="http://schemas.openxmlformats.org/presentationml/2006/main">
+  <p:cSld>
+    <p:spTree>
+      <p:nvGrpSpPr>
+        <p:cNvPr id="1" name=""/>
+        <p:cNvGrpSpPr/>
+        <p:nvPr/>
+      </p:nvGrpSpPr>
+      <p:grpSpPr>
+        <a:xfrm>
+          <a:off x="0" y="0"/>
+          <a:ext cx="0" cy="0"/>
+          <a:chOff x="0" y="0"/>
+          <a:chExt cx="0" cy="0"/>
+        </a:xfrm>
+      </p:grpSpPr>
+      <p:sp>
+        <p:nvSpPr>
+          <p:cNvPr id="2" name="Title 1"/>
+          <p:cNvSpPr>
+            <a:spLocks noGrp="1"/>
+          </p:cNvSpPr>
+          <p:nvPr>
+            <p:ph type="title"/>
+          </p:nvPr>
+        </p:nvSpPr>
+        <p:spPr/>
+        <p:txBody>
+          <a:bodyPr/>
+          <a:lstStyle/>
+          <a:p>
+            <a:pPr lvl="0" indent="0" marL="0">
+              <a:buNone/>
+            </a:pPr>
+            <a:r>
+              <a:rPr/>
+              <a:t>10. Conclusiones y próximos pasos</a:t>
+            </a:r>
+          </a:p>
+        </p:txBody>
+      </p:sp>
+      <p:sp>
+        <p:nvSpPr>
+          <p:cNvPr id="3" name="Content Placeholder 2"/>
+          <p:cNvSpPr>
+            <a:spLocks noGrp="1"/>
+          </p:cNvSpPr>
+          <p:nvPr>
+            <p:ph idx="1"/>
+          </p:nvPr>
+        </p:nvSpPr>
+        <p:spPr/>
+        <p:txBody>
+          <a:bodyPr/>
+          <a:lstStyle/>
+          <a:p>
             <a:pPr lvl="0"/>
             <a:r>
+              <a:rPr b="1"/>
+              <a:t>Insights</a:t>
+            </a:r>
+            <a:r>
               <a:rPr/>
-              <a:t>Indicadores técnicos solos: señal débil; la probabilidad depende de σ y del régimen</a:t>
+              <a:t>: niveles en k·σ252, N = 60; simulación por bloques de la acción + XLP; exceso sobre XLP </a:t>
+            </a:r>
+            <a:r>
+              <a:rPr b="1"/>
+              <a:t>no entra como señal</a:t>
+            </a:r>
+            <a:r>
+              <a:rPr/>
+              <a:t>; marca “industria no validada” fuera del piloto.</a:t>
             </a:r>
           </a:p>
           <a:p>
             <a:pPr lvl="0"/>
             <a:r>
+              <a:rPr b="1"/>
+              <a:t>Limitaciones</a:t>
+            </a:r>
+            <a:r>
               <a:rPr/>
-              <a:t>Diseño: GARCH-t con innovaciones t; rival del SVM: tasa de toque por decil de σ (GBM con deriva solo como referencia teórica, no calibrado); múltiplos como contexto</a:t>
+              <a:t>: una industria piloto; supervivencia; 3 años (no 5–10); P5 confirmatoria; fuga de selección en P4.</a:t>
             </a:r>
           </a:p>
           <a:p>
             <a:pPr lvl="0"/>
             <a:r>
+              <a:rPr b="1"/>
+              <a:t>Próximos pasos</a:t>
+            </a:r>
+            <a:r>
               <a:rPr/>
-              <a:t>Siguiente: SVM walk-forward (HT1 preparada, no probada), Monte Carlo, validación con el stakeholder</a:t>
+              <a:t>: entrenar el SVM con corte cronológico, simulación por bloques, validación con el stakeholder, segunda industria.</a:t>
             </a:r>
           </a:p>
           <a:p>
             <a:pPr lvl="0"/>
             <a:r>
               <a:rPr/>
-              <a:t>Repositorio: github.com/louis97/asistente-financiero (rama entrega-1). Video: pendiente</a:t>
+              <a:t>Repositorio: </a:t>
+            </a:r>
+            <a:r>
+              <a:rPr>
+                <a:hlinkClick r:id="rId2"/>
+              </a:rPr>
+              <a:t>https://github.com/louis97/asistente-financiero</a:t>
+            </a:r>
+            <a:r>
+              <a:rPr/>
+              <a:t>. Video: pendiente de subir.</a:t>
             </a:r>
           </a:p>
         </p:txBody>
@@ -3452,29 +3653,65 @@
           <a:p>
             <a:pPr lvl="0"/>
             <a:r>
+              <a:rPr b="1"/>
+              <a:t>Inversor value colombiano</a:t>
+            </a:r>
+            <a:r>
               <a:rPr/>
-              <a:t>Inversor value colombiano que compra acciones de EE.UU.: screener, fundamentales y gráfico en pantallas separadas</a:t>
+              <a:t> que compra acciones de EE.UU.: </a:t>
+            </a:r>
+            <a:r>
+              <a:rPr i="1"/>
+              <a:t>screener</a:t>
+            </a:r>
+            <a:r>
+              <a:rPr/>
+              <a:t>, fundamentales y gráfico en pantallas separadas; riesgo “a ojo”; sin registro de decisiones.</a:t>
             </a:r>
           </a:p>
           <a:p>
             <a:pPr lvl="0"/>
             <a:r>
               <a:rPr/>
-              <a:t>De 2 a 15 cambios de pantalla por activo; 2 a 3 horas tras cada reporte trimestral</a:t>
+              <a:t>Evidencia cualitativa (un participante + autor; muestra no representativa): </a:t>
+            </a:r>
+            <a:r>
+              <a:rPr b="1"/>
+              <a:t>2 a 15 cambios de pantalla por activo</a:t>
+            </a:r>
+            <a:r>
+              <a:rPr/>
+              <a:t>, </a:t>
+            </a:r>
+            <a:r>
+              <a:rPr b="1"/>
+              <a:t>2 a 3 horas</a:t>
+            </a:r>
+            <a:r>
+              <a:rPr/>
+              <a:t> por reporte trimestral.</a:t>
             </a:r>
           </a:p>
           <a:p>
             <a:pPr lvl="0"/>
             <a:r>
               <a:rPr/>
-              <a:t>Riesgo medido “a ojo”; sin registro de decisiones</a:t>
+              <a:t>Contexto: Mercado Global Colombiano </a:t>
+            </a:r>
+            <a:r>
+              <a:rPr b="1"/>
+              <a:t>+134 %</a:t>
+            </a:r>
+            <a:r>
+              <a:rPr/>
+              <a:t> 2024→2025 (BVC); +87 % inversionistas desde 2023 (SFC).</a:t>
             </a:r>
           </a:p>
           <a:p>
             <a:pPr lvl="0"/>
             <a:r>
               <a:rPr/>
-              <a:t>KPIs: &lt; 5 min por activo, 1 pantalla, latencia ≤ 1 día, 100 % de decisiones registradas</a:t>
+              <a:t>KPI: tiempo &lt; 5 min, 1 pantalla, latencia ≤ 1 día, 100 % decisiones registradas.</a:t>
             </a:r>
           </a:p>
         </p:txBody>
@@ -3521,41 +3758,71 @@
             </a:pPr>
             <a:r>
               <a:rPr/>
-              <a:t>2. Ideación: seis niveles, tres lecturas</a:t>
-            </a:r>
-          </a:p>
-        </p:txBody>
-      </p:sp>
-      <p:pic>
-        <p:nvPicPr>
-          <p:cNvPr descr="assets/mockup.png" id="0" name="Picture 1"/>
-          <p:cNvPicPr>
-            <a:picLocks noGrp="1" noChangeAspect="1"/>
-          </p:cNvPicPr>
-          <p:nvPr/>
-        </p:nvPicPr>
-        <p:blipFill>
-          <a:blip r:embed="rId2"/>
-          <a:stretch>
-            <a:fillRect/>
-          </a:stretch>
-        </p:blipFill>
-        <p:spPr bwMode="auto">
-          <a:xfrm>
-            <a:off x="2260600" y="1193800"/>
-            <a:ext cx="4622800" cy="3390900"/>
-          </a:xfrm>
-          <a:prstGeom prst="rect">
-            <a:avLst/>
-          </a:prstGeom>
-          <a:noFill/>
-          <a:ln w="9525">
-            <a:noFill/>
-            <a:headEnd/>
-            <a:tailEnd/>
-          </a:ln>
-        </p:spPr>
-      </p:pic>
+              <a:t>2. Producto: seis niveles, tres lecturas</a:t>
+            </a:r>
+          </a:p>
+        </p:txBody>
+      </p:sp>
+      <p:sp>
+        <p:nvSpPr>
+          <p:cNvPr id="3" name="Content Placeholder 2"/>
+          <p:cNvSpPr>
+            <a:spLocks noGrp="1"/>
+          </p:cNvSpPr>
+          <p:nvPr>
+            <p:ph idx="1"/>
+          </p:nvPr>
+        </p:nvSpPr>
+        <p:spPr/>
+        <p:txBody>
+          <a:bodyPr/>
+          <a:lstStyle/>
+          <a:p>
+            <a:pPr lvl="0"/>
+            <a:r>
+              <a:rPr b="1"/>
+              <a:t>6 niveles</a:t>
+            </a:r>
+            <a:r>
+              <a:rPr/>
+              <a:t> definidos por el usuario (3 de entrada, 3 de salida), en precio y en múltiplo.</a:t>
+            </a:r>
+          </a:p>
+          <a:p>
+            <a:pPr lvl="0"/>
+            <a:r>
+              <a:rPr b="1"/>
+              <a:t>3 lecturas</a:t>
+            </a:r>
+            <a:r>
+              <a:rPr/>
+              <a:t> por nivel: fundamental (percentiles del P/E normalizado), técnica (SVM, N = 60 días), probabilística (simulación por bloques de la acción y del XLP).</a:t>
+            </a:r>
+          </a:p>
+          <a:p>
+            <a:pPr lvl="0"/>
+            <a:r>
+              <a:rPr b="1"/>
+              <a:t>Panel de riesgo</a:t>
+            </a:r>
+            <a:r>
+              <a:rPr/>
+              <a:t> descriptivo: volatilidad, percentil 5, caída máxima, caídas fuertes, dependencia del sector.</a:t>
+            </a:r>
+          </a:p>
+          <a:p>
+            <a:pPr lvl="0"/>
+            <a:r>
+              <a:rPr b="1"/>
+              <a:t>Alcance de la entrega 1</a:t>
+            </a:r>
+            <a:r>
+              <a:rPr/>
+              <a:t>: industria piloto consumo defensivo (21 empresas + SPY + XLP; KHC excluida).</a:t>
+            </a:r>
+          </a:p>
+        </p:txBody>
+      </p:sp>
     </p:spTree>
   </p:cSld>
 </p:sld>
@@ -3580,27 +3847,59 @@
       </p:grpSpPr>
       <p:sp>
         <p:nvSpPr>
-          <p:cNvPr id="3" name="Content Placeholder 2"/>
-          <p:cNvSpPr>
-            <a:spLocks noGrp="1"/>
-          </p:cNvSpPr>
-          <p:nvPr>
-            <p:ph idx="1"/>
-          </p:nvPr>
-        </p:nvSpPr>
-        <p:spPr/>
-        <p:txBody>
-          <a:bodyPr/>
-          <a:lstStyle/>
-          <a:p>
-            <a:pPr lvl="0"/>
+          <p:cNvPr id="2" name="Title 1"/>
+          <p:cNvSpPr>
+            <a:spLocks noGrp="1"/>
+          </p:cNvSpPr>
+          <p:nvPr>
+            <p:ph type="title"/>
+          </p:nvPr>
+        </p:nvSpPr>
+        <p:spPr/>
+        <p:txBody>
+          <a:bodyPr/>
+          <a:lstStyle/>
+          <a:p>
+            <a:pPr lvl="0" indent="0" marL="0">
+              <a:buNone/>
+            </a:pPr>
             <a:r>
               <a:rPr/>
-              <a:t>Validación con el stakeholder: pendiente</a:t>
-            </a:r>
-          </a:p>
-        </p:txBody>
-      </p:sp>
+              <a:t>3. Mockup</a:t>
+            </a:r>
+          </a:p>
+        </p:txBody>
+      </p:sp>
+      <p:pic>
+        <p:nvPicPr>
+          <p:cNvPr descr="assets/mockup.png" id="0" name="Picture 1"/>
+          <p:cNvPicPr>
+            <a:picLocks noGrp="1" noChangeAspect="1"/>
+          </p:cNvPicPr>
+          <p:nvPr/>
+        </p:nvPicPr>
+        <p:blipFill>
+          <a:blip r:embed="rId2"/>
+          <a:stretch>
+            <a:fillRect/>
+          </a:stretch>
+        </p:blipFill>
+        <p:spPr bwMode="auto">
+          <a:xfrm>
+            <a:off x="2819400" y="1193800"/>
+            <a:ext cx="3505200" cy="3390900"/>
+          </a:xfrm>
+          <a:prstGeom prst="rect">
+            <a:avLst/>
+          </a:prstGeom>
+          <a:noFill/>
+          <a:ln w="9525">
+            <a:noFill/>
+            <a:headEnd/>
+            <a:tailEnd/>
+          </a:ln>
+        </p:spPr>
+      </p:pic>
     </p:spTree>
   </p:cSld>
 </p:sld>
@@ -3625,12 +3924,12 @@
       </p:grpSpPr>
       <p:sp>
         <p:nvSpPr>
-          <p:cNvPr id="2" name="Title 1"/>
-          <p:cNvSpPr>
-            <a:spLocks noGrp="1"/>
-          </p:cNvSpPr>
-          <p:nvPr>
-            <p:ph type="title"/>
+          <p:cNvPr id="3" name="Content Placeholder 2"/>
+          <p:cNvSpPr>
+            <a:spLocks noGrp="1"/>
+          </p:cNvSpPr>
+          <p:nvPr>
+            <p:ph idx="1"/>
           </p:nvPr>
         </p:nvSpPr>
         <p:spPr/>
@@ -3643,61 +3942,15 @@
             </a:pPr>
             <a:r>
               <a:rPr/>
-              <a:t>3. Ética y regulación</a:t>
-            </a:r>
-          </a:p>
-        </p:txBody>
-      </p:sp>
-      <p:sp>
-        <p:nvSpPr>
-          <p:cNvPr id="3" name="Content Placeholder 2"/>
-          <p:cNvSpPr>
-            <a:spLocks noGrp="1"/>
-          </p:cNvSpPr>
-          <p:nvPr>
-            <p:ph idx="1"/>
-          </p:nvPr>
-        </p:nvSpPr>
-        <p:spPr/>
-        <p:txBody>
-          <a:bodyPr/>
-          <a:lstStyle/>
-          <a:p>
-            <a:pPr lvl="0"/>
+              <a:t>Validación con el stakeholder: </a:t>
+            </a:r>
+            <a:r>
+              <a:rPr b="1"/>
+              <a:t>pendiente</a:t>
+            </a:r>
             <a:r>
               <a:rPr/>
-              <a:t>Sin recomendación de compra o venta (Ley 964 de 2005); aviso en cada pantalla</a:t>
-            </a:r>
-          </a:p>
-          <a:p>
-            <a:pPr lvl="0"/>
-            <a:r>
-              <a:rPr/>
-              <a:t>Datos personales anonimizados (Ley 1581 de 2012)</a:t>
-            </a:r>
-          </a:p>
-          <a:p>
-            <a:pPr lvl="0"/>
-            <a:r>
-              <a:rPr/>
-              <a:t>SVM lineal explicable, frente a la tasa de toque por decil de σ (GBM como referencia) y con error histórico</a:t>
-            </a:r>
-          </a:p>
-          <a:p>
-            <a:pPr lvl="0"/>
-            <a:r>
-              <a:rPr/>
-              <a:t>Sin look-ahead: fecha </a:t>
-            </a:r>
-            <a:r>
-              <a:rPr>
-                <a:latin typeface="Courier"/>
-              </a:rPr>
-              <a:t>filed</a:t>
-            </a:r>
-            <a:r>
-              <a:rPr/>
-              <a:t>, purga y embargo</a:t>
+              <a:t> (sesión 2026-10-16).</a:t>
             </a:r>
           </a:p>
         </p:txBody>
@@ -3744,7 +3997,7 @@
             </a:pPr>
             <a:r>
               <a:rPr/>
-              <a:t>4. Enfoque analítico</a:t>
+              <a:t>4. Ética y regulación</a:t>
             </a:r>
           </a:p>
         </p:txBody>
@@ -3766,29 +4019,55 @@
           <a:p>
             <a:pPr lvl="0"/>
             <a:r>
+              <a:rPr b="1"/>
+              <a:t>Ley 964 de 2005 y Decreto 2555 de 2010</a:t>
+            </a:r>
+            <a:r>
               <a:rPr/>
-              <a:t>Preguntas de negocio a hipótesis HT, HF y HP con H0 y H1</a:t>
+              <a:t>: el producto no recomienda compra ni venta y no perfila al usuario; leyenda del art. 2.40.1.1.3 en cada pantalla.</a:t>
             </a:r>
           </a:p>
           <a:p>
             <a:pPr lvl="0"/>
             <a:r>
+              <a:rPr b="1"/>
+              <a:t>Habeas Data (Ley 1581 de 2012)</a:t>
+            </a:r>
+            <a:r>
               <a:rPr/>
-              <a:t>Etiqueta de triple barrera solo-largo (k = 1, N = 12)</a:t>
+              <a:t>: anonimización del participante y autorización verificable.</a:t>
             </a:r>
           </a:p>
           <a:p>
             <a:pPr lvl="0"/>
             <a:r>
+              <a:rPr b="1"/>
+              <a:t>Transparencia</a:t>
+            </a:r>
+            <a:r>
               <a:rPr/>
-              <a:t>Validación walk-forward con purga y embargo</a:t>
+              <a:t>: SVM lineal con coeficientes legibles; probabilidad junto a su línea base y su desempeño histórico.</a:t>
             </a:r>
           </a:p>
           <a:p>
             <a:pPr lvl="0"/>
             <a:r>
+              <a:rPr b="1"/>
+              <a:t>Sin look-ahead ni data snooping</a:t>
+            </a:r>
+            <a:r>
               <a:rPr/>
-              <a:t>Cuatro líneas base (decide HT1 la tasa de toque por decil de σ); IC bootstrap para declarar una hipótesis apoyada</a:t>
+              <a:t>: fecha </a:t>
+            </a:r>
+            <a:r>
+              <a:rPr>
+                <a:latin typeface="Courier"/>
+              </a:rPr>
+              <a:t>filed</a:t>
+            </a:r>
+            <a:r>
+              <a:rPr/>
+              <a:t>, ventana expansiva, 15 pruebas declaradas antes, Bonferroni en P4.</a:t>
             </a:r>
           </a:p>
         </p:txBody>
@@ -3835,11 +4114,372 @@
             </a:pPr>
             <a:r>
               <a:rPr/>
-              <a:t>5. Datos</a:t>
-            </a:r>
-          </a:p>
-        </p:txBody>
-      </p:sp>
+              <a:t>5. Enfoque analítico (6 preguntas, 1 hipótesis cada una)</a:t>
+            </a:r>
+          </a:p>
+        </p:txBody>
+      </p:sp>
+      <p:graphicFrame>
+        <p:nvGraphicFramePr>
+          <p:cNvPr id="6" name="Content Placeholder 5"/>
+          <p:cNvGraphicFramePr>
+            <a:graphicFrameLocks noGrp="1"/>
+          </p:cNvGraphicFramePr>
+          <p:nvPr>
+            <p:ph idx="1"/>
+          </p:nvPr>
+        </p:nvGraphicFramePr>
+        <p:xfrm>
+          <a:off x="457200" y="1193800"/>
+          <a:ext cx="8229600" cy="2514600"/>
+        </p:xfrm>
+        <a:graphic>
+          <a:graphicData uri="http://schemas.openxmlformats.org/drawingml/2006/table">
+            <a:tbl>
+              <a:tblPr firstRow="1" bandRow="1">
+                <a:tableStyleId>{5C22544A-7EE6-4342-B048-85BDC9FD1C3A}</a:tableStyleId>
+              </a:tblPr>
+              <a:tblGrid>
+                <a:gridCol w="2743200"/>
+                <a:gridCol w="2743200"/>
+                <a:gridCol w="2743200"/>
+              </a:tblGrid>
+              <a:tr h="0">
+                <a:tc>
+                  <a:txBody>
+                    <a:bodyPr/>
+                    <a:lstStyle/>
+                    <a:p>
+                      <a:pPr lvl="0" indent="0" marL="0">
+                        <a:buNone/>
+                      </a:pPr>
+                      <a:r>
+                        <a:rPr/>
+                        <a:t>Preg.</a:t>
+                      </a:r>
+                    </a:p>
+                  </a:txBody>
+                  <a:tcPr/>
+                </a:tc>
+                <a:tc>
+                  <a:txBody>
+                    <a:bodyPr/>
+                    <a:lstStyle/>
+                    <a:p>
+                      <a:pPr lvl="0" indent="0" marL="0">
+                        <a:buNone/>
+                      </a:pPr>
+                      <a:r>
+                        <a:rPr/>
+                        <a:t>Qué pregunta</a:t>
+                      </a:r>
+                    </a:p>
+                  </a:txBody>
+                  <a:tcPr/>
+                </a:tc>
+                <a:tc>
+                  <a:txBody>
+                    <a:bodyPr/>
+                    <a:lstStyle/>
+                    <a:p>
+                      <a:pPr lvl="0" indent="0" marL="0">
+                        <a:buNone/>
+                      </a:pPr>
+                      <a:r>
+                        <a:rPr/>
+                        <a:t>Umbral</a:t>
+                      </a:r>
+                    </a:p>
+                  </a:txBody>
+                  <a:tcPr/>
+                </a:tc>
+              </a:tr>
+              <a:tr h="0">
+                <a:tc>
+                  <a:txBody>
+                    <a:bodyPr/>
+                    <a:lstStyle/>
+                    <a:p>
+                      <a:pPr lvl="0" indent="0" marL="0">
+                        <a:buNone/>
+                      </a:pPr>
+                      <a:r>
+                        <a:rPr/>
+                        <a:t>P1</a:t>
+                      </a:r>
+                    </a:p>
+                  </a:txBody>
+                </a:tc>
+                <a:tc>
+                  <a:txBody>
+                    <a:bodyPr/>
+                    <a:lstStyle/>
+                    <a:p>
+                      <a:pPr lvl="0" indent="0" marL="0">
+                        <a:buNone/>
+                      </a:pPr>
+                      <a:r>
+                        <a:rPr/>
+                        <a:t>¿Caídas semanales &gt; 2σ más frecuentes que una normal?</a:t>
+                      </a:r>
+                    </a:p>
+                  </a:txBody>
+                </a:tc>
+                <a:tc>
+                  <a:txBody>
+                    <a:bodyPr/>
+                    <a:lstStyle/>
+                    <a:p>
+                      <a:pPr lvl="0" indent="0" marL="0">
+                        <a:buNone/>
+                      </a:pPr>
+                      <a:r>
+                        <a:rPr/>
+                        <a:t>3,8 %</a:t>
+                      </a:r>
+                    </a:p>
+                  </a:txBody>
+                </a:tc>
+              </a:tr>
+              <a:tr h="0">
+                <a:tc>
+                  <a:txBody>
+                    <a:bodyPr/>
+                    <a:lstStyle/>
+                    <a:p>
+                      <a:pPr lvl="0" indent="0" marL="0">
+                        <a:buNone/>
+                      </a:pPr>
+                      <a:r>
+                        <a:rPr/>
+                        <a:t>P2</a:t>
+                      </a:r>
+                    </a:p>
+                  </a:txBody>
+                </a:tc>
+                <a:tc>
+                  <a:txBody>
+                    <a:bodyPr/>
+                    <a:lstStyle/>
+                    <a:p>
+                      <a:pPr lvl="0" indent="0" marL="0">
+                        <a:buNone/>
+                      </a:pPr>
+                      <a:r>
+                        <a:rPr/>
+                        <a:t>¿Barato &gt; caro a 3 años en Δlog(P/E normalizado)?</a:t>
+                      </a:r>
+                    </a:p>
+                  </a:txBody>
+                </a:tc>
+                <a:tc>
+                  <a:txBody>
+                    <a:bodyPr/>
+                    <a:lstStyle/>
+                    <a:p>
+                      <a:pPr lvl="0" indent="0" marL="0">
+                        <a:buNone/>
+                      </a:pPr>
+                      <a:r>
+                        <a:rPr/>
+                        <a:t>+0,03 anualizado</a:t>
+                      </a:r>
+                    </a:p>
+                  </a:txBody>
+                </a:tc>
+              </a:tr>
+              <a:tr h="0">
+                <a:tc>
+                  <a:txBody>
+                    <a:bodyPr/>
+                    <a:lstStyle/>
+                    <a:p>
+                      <a:pPr lvl="0" indent="0" marL="0">
+                        <a:buNone/>
+                      </a:pPr>
+                      <a:r>
+                        <a:rPr/>
+                        <a:t>P3</a:t>
+                      </a:r>
+                    </a:p>
+                  </a:txBody>
+                </a:tc>
+                <a:tc>
+                  <a:txBody>
+                    <a:bodyPr/>
+                    <a:lstStyle/>
+                    <a:p>
+                      <a:pPr lvl="0" indent="0" marL="0">
+                        <a:buNone/>
+                      </a:pPr>
+                      <a:r>
+                        <a:rPr/>
+                        <a:t>¿Barato gana al XLP a 3 años?</a:t>
+                      </a:r>
+                    </a:p>
+                  </a:txBody>
+                </a:tc>
+                <a:tc>
+                  <a:txBody>
+                    <a:bodyPr/>
+                    <a:lstStyle/>
+                    <a:p>
+                      <a:pPr lvl="0" indent="0" marL="0">
+                        <a:buNone/>
+                      </a:pPr>
+                      <a:r>
+                        <a:rPr/>
+                        <a:t>+0,05 anualizado</a:t>
+                      </a:r>
+                    </a:p>
+                  </a:txBody>
+                </a:tc>
+              </a:tr>
+              <a:tr h="0">
+                <a:tc>
+                  <a:txBody>
+                    <a:bodyPr/>
+                    <a:lstStyle/>
+                    <a:p>
+                      <a:pPr lvl="0" indent="0" marL="0">
+                        <a:buNone/>
+                      </a:pPr>
+                      <a:r>
+                        <a:rPr/>
+                        <a:t>P4</a:t>
+                      </a:r>
+                    </a:p>
+                  </a:txBody>
+                </a:tc>
+                <a:tc>
+                  <a:txBody>
+                    <a:bodyPr/>
+                    <a:lstStyle/>
+                    <a:p>
+                      <a:pPr lvl="0" indent="0" marL="0">
+                        <a:buNone/>
+                      </a:pPr>
+                      <a:r>
+                        <a:rPr/>
+                        <a:t>¿Algún indicador técnico mejora la AUC base?</a:t>
+                      </a:r>
+                    </a:p>
+                  </a:txBody>
+                </a:tc>
+                <a:tc>
+                  <a:txBody>
+                    <a:bodyPr/>
+                    <a:lstStyle/>
+                    <a:p>
+                      <a:pPr lvl="0" indent="0" marL="0">
+                        <a:buNone/>
+                      </a:pPr>
+                      <a:r>
+                        <a:rPr/>
+                        <a:t>+0,01 (×7)</a:t>
+                      </a:r>
+                    </a:p>
+                  </a:txBody>
+                </a:tc>
+              </a:tr>
+              <a:tr h="0">
+                <a:tc>
+                  <a:txBody>
+                    <a:bodyPr/>
+                    <a:lstStyle/>
+                    <a:p>
+                      <a:pPr lvl="0" indent="0" marL="0">
+                        <a:buNone/>
+                      </a:pPr>
+                      <a:r>
+                        <a:rPr/>
+                        <a:t>P5</a:t>
+                      </a:r>
+                    </a:p>
+                  </a:txBody>
+                </a:tc>
+                <a:tc>
+                  <a:txBody>
+                    <a:bodyPr/>
+                    <a:lstStyle/>
+                    <a:p>
+                      <a:pPr lvl="0" indent="0" marL="0">
+                        <a:buNone/>
+                      </a:pPr>
+                      <a:r>
+                        <a:rPr/>
+                        <a:t>¿XLP agrega ΔR² al SPY?</a:t>
+                      </a:r>
+                    </a:p>
+                  </a:txBody>
+                </a:tc>
+                <a:tc>
+                  <a:txBody>
+                    <a:bodyPr/>
+                    <a:lstStyle/>
+                    <a:p>
+                      <a:pPr lvl="0" indent="0" marL="0">
+                        <a:buNone/>
+                      </a:pPr>
+                      <a:r>
+                        <a:rPr/>
+                        <a:t>+0,05</a:t>
+                      </a:r>
+                    </a:p>
+                  </a:txBody>
+                </a:tc>
+              </a:tr>
+              <a:tr h="0">
+                <a:tc>
+                  <a:txBody>
+                    <a:bodyPr/>
+                    <a:lstStyle/>
+                    <a:p>
+                      <a:pPr lvl="0" indent="0" marL="0">
+                        <a:buNone/>
+                      </a:pPr>
+                      <a:r>
+                        <a:rPr/>
+                        <a:t>P6</a:t>
+                      </a:r>
+                    </a:p>
+                  </a:txBody>
+                </a:tc>
+                <a:tc>
+                  <a:txBody>
+                    <a:bodyPr/>
+                    <a:lstStyle/>
+                    <a:p>
+                      <a:pPr lvl="0" indent="0" marL="0">
+                        <a:buNone/>
+                      </a:pPr>
+                      <a:r>
+                        <a:rPr/>
+                        <a:t>¿La turbulencia se agrupa?</a:t>
+                      </a:r>
+                    </a:p>
+                  </a:txBody>
+                </a:tc>
+                <a:tc>
+                  <a:txBody>
+                    <a:bodyPr/>
+                    <a:lstStyle/>
+                    <a:p>
+                      <a:pPr lvl="0" indent="0" marL="0">
+                        <a:buNone/>
+                      </a:pPr>
+                      <a:r>
+                        <a:rPr/>
+                        <a:t>0,30</a:t>
+                      </a:r>
+                    </a:p>
+                  </a:txBody>
+                </a:tc>
+              </a:tr>
+            </a:tbl>
+          </a:graphicData>
+        </a:graphic>
+      </p:graphicFrame>
       <p:sp>
         <p:nvSpPr>
           <p:cNvPr id="3" name="Content Placeholder 2"/>
@@ -3850,36 +4490,22 @@
             <p:ph idx="1"/>
           </p:nvPr>
         </p:nvSpPr>
-        <p:spPr/>
-        <p:txBody>
-          <a:bodyPr/>
-          <a:lstStyle/>
-          <a:p>
-            <a:pPr lvl="0"/>
+        <p:spPr>
+          <a:xfrm>
+            <a:off x="457200" y="3835400"/>
+            <a:ext cx="8229600" cy="622300"/>
+          </a:xfrm>
+        </p:spPr>
+        <p:txBody>
+          <a:bodyPr/>
+          <a:lstStyle/>
+          <a:p>
+            <a:pPr lvl="0" indent="0" marL="0">
+              <a:buNone/>
+            </a:pPr>
             <a:r>
               <a:rPr/>
-              <a:t>yfinance, SEC EDGAR y Damodaran (gratuitos)</a:t>
-            </a:r>
-          </a:p>
-          <a:p>
-            <a:pPr lvl="0"/>
-            <a:r>
-              <a:rPr/>
-              <a:t>30 acciones y 4 ETF; 27 326 filas semanales desde 2009</a:t>
-            </a:r>
-          </a:p>
-          <a:p>
-            <a:pPr lvl="0"/>
-            <a:r>
-              <a:rPr/>
-              <a:t>Utilidad bruta presente en solo 14 de 30 emisores</a:t>
-            </a:r>
-          </a:p>
-          <a:p>
-            <a:pPr lvl="0"/>
-            <a:r>
-              <a:rPr/>
-              <a:t>EDGAR coincide en 6 de 6 con el 10-K de AAPL, KO y JPM</a:t>
+              <a:t>Plantilla: umbral → H0/H1 → prueba y supuestos → IC95 por bootstrap → decisión estadística y de negocio.</a:t>
             </a:r>
           </a:p>
         </p:txBody>
@@ -3926,41 +4552,77 @@
             </a:pPr>
             <a:r>
               <a:rPr/>
-              <a:t>6. EDA: riesgo y colas</a:t>
-            </a:r>
-          </a:p>
-        </p:txBody>
-      </p:sp>
-      <p:pic>
-        <p:nvPicPr>
-          <p:cNvPr descr="assets/vol_ewma_garch.png" id="0" name="Picture 1"/>
-          <p:cNvPicPr>
-            <a:picLocks noGrp="1" noChangeAspect="1"/>
-          </p:cNvPicPr>
-          <p:nvPr/>
-        </p:nvPicPr>
-        <p:blipFill>
-          <a:blip r:embed="rId2"/>
-          <a:stretch>
-            <a:fillRect/>
-          </a:stretch>
-        </p:blipFill>
-        <p:spPr bwMode="auto">
-          <a:xfrm>
-            <a:off x="457200" y="1879600"/>
-            <a:ext cx="8229600" cy="2019300"/>
-          </a:xfrm>
-          <a:prstGeom prst="rect">
-            <a:avLst/>
-          </a:prstGeom>
-          <a:noFill/>
-          <a:ln w="9525">
-            <a:noFill/>
-            <a:headEnd/>
-            <a:tailEnd/>
-          </a:ln>
-        </p:spPr>
-      </p:pic>
+              <a:t>6. Datos (tres fuentes gratuitas, instantánea fechada)</a:t>
+            </a:r>
+          </a:p>
+        </p:txBody>
+      </p:sp>
+      <p:sp>
+        <p:nvSpPr>
+          <p:cNvPr id="3" name="Content Placeholder 2"/>
+          <p:cNvSpPr>
+            <a:spLocks noGrp="1"/>
+          </p:cNvSpPr>
+          <p:nvPr>
+            <p:ph idx="1"/>
+          </p:nvPr>
+        </p:nvSpPr>
+        <p:spPr/>
+        <p:txBody>
+          <a:bodyPr/>
+          <a:lstStyle/>
+          <a:p>
+            <a:pPr lvl="0"/>
+            <a:r>
+              <a:rPr b="1"/>
+              <a:t>yfinance</a:t>
+            </a:r>
+            <a:r>
+              <a:rPr/>
+              <a:t>: 21 344 filas semanales × 23 tickers desde 2009; precios ajustados y sin ajustar por dividendos.</a:t>
+            </a:r>
+          </a:p>
+          <a:p>
+            <a:pPr lvl="0"/>
+            <a:r>
+              <a:rPr b="1"/>
+              <a:t>SEC EDGAR</a:t>
+            </a:r>
+            <a:r>
+              <a:rPr/>
+              <a:t>: hechos XBRL de los 10-K y 10-Q con fecha </a:t>
+            </a:r>
+            <a:r>
+              <a:rPr>
+                <a:latin typeface="Courier"/>
+              </a:rPr>
+              <a:t>filed</a:t>
+            </a:r>
+            <a:r>
+              <a:rPr/>
+              <a:t>; el P/E usa el EPS TTM reconstruido con los 10-Q.</a:t>
+            </a:r>
+          </a:p>
+          <a:p>
+            <a:pPr lvl="0"/>
+            <a:r>
+              <a:rPr b="1"/>
+              <a:t>Damodaran</a:t>
+            </a:r>
+            <a:r>
+              <a:rPr/>
+              <a:t>: múltiplos y márgenes por industria.</a:t>
+            </a:r>
+          </a:p>
+          <a:p>
+            <a:pPr lvl="0"/>
+            <a:r>
+              <a:rPr/>
+              <a:t>Calidad en nb02: 9 dimensiones y 5 niveles; 0 nulos en precios ajustados, 0 duplicados; TTM válido en 1.308 de 1.434 trimestres (91,2 %).</a:t>
+            </a:r>
+          </a:p>
+        </p:txBody>
+      </p:sp>
     </p:spTree>
   </p:cSld>
 </p:sld>
@@ -3985,41 +4647,331 @@
       </p:grpSpPr>
       <p:sp>
         <p:nvSpPr>
-          <p:cNvPr id="3" name="Content Placeholder 2"/>
-          <p:cNvSpPr>
-            <a:spLocks noGrp="1"/>
-          </p:cNvSpPr>
+          <p:cNvPr id="2" name="Title 1"/>
+          <p:cNvSpPr>
+            <a:spLocks noGrp="1"/>
+          </p:cNvSpPr>
+          <p:nvPr>
+            <p:ph type="title"/>
+          </p:nvPr>
+        </p:nvSpPr>
+        <p:spPr/>
+        <p:txBody>
+          <a:bodyPr/>
+          <a:lstStyle/>
+          <a:p>
+            <a:pPr lvl="0" indent="0" marL="0">
+              <a:buNone/>
+            </a:pPr>
+            <a:r>
+              <a:rPr/>
+              <a:t>7. EDA: resultados por hipótesis</a:t>
+            </a:r>
+          </a:p>
+        </p:txBody>
+      </p:sp>
+      <p:graphicFrame>
+        <p:nvGraphicFramePr>
+          <p:cNvPr id="6" name="Content Placeholder 5"/>
+          <p:cNvGraphicFramePr>
+            <a:graphicFrameLocks noGrp="1"/>
+          </p:cNvGraphicFramePr>
           <p:nvPr>
             <p:ph idx="1"/>
           </p:nvPr>
-        </p:nvSpPr>
-        <p:spPr/>
-        <p:txBody>
-          <a:bodyPr/>
-          <a:lstStyle/>
-          <a:p>
-            <a:pPr lvl="0"/>
-            <a:r>
-              <a:rPr/>
-              <a:t>ν mediano 4.15; GARCH-t gana en 28 de 34 series (HP0, HT4 apoyadas)</a:t>
-            </a:r>
-          </a:p>
-          <a:p>
-            <a:pPr lvl="0"/>
-            <a:r>
-              <a:rPr/>
-              <a:t>Caminata aleatoria: pasan 15 de 30 (HT0 no apoyada); P_GBM no calibrada</a:t>
-            </a:r>
-          </a:p>
-          <a:p>
-            <a:pPr lvl="0"/>
-            <a:r>
-              <a:rPr/>
-              <a:t>VaR: GARCH-t adecuado en 14 de 30 (HP1 no apoyada)</a:t>
-            </a:r>
-          </a:p>
-        </p:txBody>
-      </p:sp>
+        </p:nvGraphicFramePr>
+        <p:xfrm>
+          <a:off x="457200" y="1193800"/>
+          <a:ext cx="8229600" cy="3390900"/>
+        </p:xfrm>
+        <a:graphic>
+          <a:graphicData uri="http://schemas.openxmlformats.org/drawingml/2006/table">
+            <a:tbl>
+              <a:tblPr firstRow="1" bandRow="1">
+                <a:tableStyleId>{5C22544A-7EE6-4342-B048-85BDC9FD1C3A}</a:tableStyleId>
+              </a:tblPr>
+              <a:tblGrid>
+                <a:gridCol w="4114800"/>
+                <a:gridCol w="4114800"/>
+              </a:tblGrid>
+              <a:tr h="0">
+                <a:tc>
+                  <a:txBody>
+                    <a:bodyPr/>
+                    <a:lstStyle/>
+                    <a:p>
+                      <a:pPr lvl="0" indent="0" marL="0">
+                        <a:buNone/>
+                      </a:pPr>
+                      <a:r>
+                        <a:rPr/>
+                        <a:t>Preg.</a:t>
+                      </a:r>
+                    </a:p>
+                  </a:txBody>
+                  <a:tcPr/>
+                </a:tc>
+                <a:tc>
+                  <a:txBody>
+                    <a:bodyPr/>
+                    <a:lstStyle/>
+                    <a:p>
+                      <a:pPr lvl="0" indent="0" marL="0">
+                        <a:buNone/>
+                      </a:pPr>
+                      <a:r>
+                        <a:rPr/>
+                        <a:t>Estimado · IC95 · Decisión</a:t>
+                      </a:r>
+                    </a:p>
+                  </a:txBody>
+                  <a:tcPr/>
+                </a:tc>
+              </a:tr>
+              <a:tr h="0">
+                <a:tc>
+                  <a:txBody>
+                    <a:bodyPr/>
+                    <a:lstStyle/>
+                    <a:p>
+                      <a:pPr lvl="0" indent="0" marL="0">
+                        <a:buNone/>
+                      </a:pPr>
+                      <a:r>
+                        <a:rPr/>
+                        <a:t>P1</a:t>
+                      </a:r>
+                    </a:p>
+                  </a:txBody>
+                </a:tc>
+                <a:tc>
+                  <a:txBody>
+                    <a:bodyPr/>
+                    <a:lstStyle/>
+                    <a:p>
+                      <a:pPr lvl="0" indent="0" marL="0">
+                        <a:buNone/>
+                      </a:pPr>
+                      <a:r>
+                        <a:rPr/>
+                        <a:t>3,08 % · [2,46; 3,92] % · </a:t>
+                      </a:r>
+                      <a:r>
+                        <a:rPr b="1"/>
+                        <a:t>no se rechaza H0</a:t>
+                      </a:r>
+                      <a:r>
+                        <a:rPr/>
+                        <a:t>, no accionable</a:t>
+                      </a:r>
+                    </a:p>
+                  </a:txBody>
+                </a:tc>
+              </a:tr>
+              <a:tr h="0">
+                <a:tc>
+                  <a:txBody>
+                    <a:bodyPr/>
+                    <a:lstStyle/>
+                    <a:p>
+                      <a:pPr lvl="0" indent="0" marL="0">
+                        <a:buNone/>
+                      </a:pPr>
+                      <a:r>
+                        <a:rPr/>
+                        <a:t>P2</a:t>
+                      </a:r>
+                    </a:p>
+                  </a:txBody>
+                </a:tc>
+                <a:tc>
+                  <a:txBody>
+                    <a:bodyPr/>
+                    <a:lstStyle/>
+                    <a:p>
+                      <a:pPr lvl="0" indent="0" marL="0">
+                        <a:buNone/>
+                      </a:pPr>
+                      <a:r>
+                        <a:rPr/>
+                        <a:t>+0,153 · [+0,091; +0,221] · </a:t>
+                      </a:r>
+                      <a:r>
+                        <a:rPr b="1"/>
+                        <a:t>se rechaza H0</a:t>
+                      </a:r>
+                      <a:r>
+                        <a:rPr/>
+                        <a:t>, accionable</a:t>
+                      </a:r>
+                    </a:p>
+                  </a:txBody>
+                </a:tc>
+              </a:tr>
+              <a:tr h="0">
+                <a:tc>
+                  <a:txBody>
+                    <a:bodyPr/>
+                    <a:lstStyle/>
+                    <a:p>
+                      <a:pPr lvl="0" indent="0" marL="0">
+                        <a:buNone/>
+                      </a:pPr>
+                      <a:r>
+                        <a:rPr/>
+                        <a:t>P3</a:t>
+                      </a:r>
+                    </a:p>
+                  </a:txBody>
+                </a:tc>
+                <a:tc>
+                  <a:txBody>
+                    <a:bodyPr/>
+                    <a:lstStyle/>
+                    <a:p>
+                      <a:pPr lvl="0" indent="0" marL="0">
+                        <a:buNone/>
+                      </a:pPr>
+                      <a:r>
+                        <a:rPr/>
+                        <a:t>+0,006 · [−0,032; +0,049] · </a:t>
+                      </a:r>
+                      <a:r>
+                        <a:rPr b="1"/>
+                        <a:t>no se rechaza H0</a:t>
+                      </a:r>
+                      <a:r>
+                        <a:rPr/>
+                        <a:t>, no accionable</a:t>
+                      </a:r>
+                    </a:p>
+                  </a:txBody>
+                </a:tc>
+              </a:tr>
+              <a:tr h="0">
+                <a:tc>
+                  <a:txBody>
+                    <a:bodyPr/>
+                    <a:lstStyle/>
+                    <a:p>
+                      <a:pPr lvl="0" indent="0" marL="0">
+                        <a:buNone/>
+                      </a:pPr>
+                      <a:r>
+                        <a:rPr/>
+                        <a:t>P4</a:t>
+                      </a:r>
+                    </a:p>
+                  </a:txBody>
+                </a:tc>
+                <a:tc>
+                  <a:txBody>
+                    <a:bodyPr/>
+                    <a:lstStyle/>
+                    <a:p>
+                      <a:pPr lvl="0" indent="0" marL="0">
+                        <a:buNone/>
+                      </a:pPr>
+                      <a:r>
+                        <a:rPr/>
+                        <a:t>7 indicadores con IC que cruzan 0 · </a:t>
+                      </a:r>
+                      <a:r>
+                        <a:rPr b="1"/>
+                        <a:t>no se rechaza H0</a:t>
+                      </a:r>
+                      <a:r>
+                        <a:rPr/>
+                        <a:t> (×7)</a:t>
+                      </a:r>
+                    </a:p>
+                  </a:txBody>
+                </a:tc>
+              </a:tr>
+              <a:tr h="0">
+                <a:tc>
+                  <a:txBody>
+                    <a:bodyPr/>
+                    <a:lstStyle/>
+                    <a:p>
+                      <a:pPr lvl="0" indent="0" marL="0">
+                        <a:buNone/>
+                      </a:pPr>
+                      <a:r>
+                        <a:rPr/>
+                        <a:t>P5</a:t>
+                      </a:r>
+                    </a:p>
+                  </a:txBody>
+                </a:tc>
+                <a:tc>
+                  <a:txBody>
+                    <a:bodyPr/>
+                    <a:lstStyle/>
+                    <a:p>
+                      <a:pPr lvl="0" indent="0" marL="0">
+                        <a:buNone/>
+                      </a:pPr>
+                      <a:r>
+                        <a:rPr/>
+                        <a:t>ΔR² 0,225 · [+0,175; +0,291] · </a:t>
+                      </a:r>
+                      <a:r>
+                        <a:rPr b="1"/>
+                        <a:t>se rechaza H0</a:t>
+                      </a:r>
+                      <a:r>
+                        <a:rPr/>
+                        <a:t>, accionable (confirmatoria)</a:t>
+                      </a:r>
+                    </a:p>
+                  </a:txBody>
+                </a:tc>
+              </a:tr>
+              <a:tr h="0">
+                <a:tc>
+                  <a:txBody>
+                    <a:bodyPr/>
+                    <a:lstStyle/>
+                    <a:p>
+                      <a:pPr lvl="0" indent="0" marL="0">
+                        <a:buNone/>
+                      </a:pPr>
+                      <a:r>
+                        <a:rPr/>
+                        <a:t>P6 d.</a:t>
+                      </a:r>
+                    </a:p>
+                  </a:txBody>
+                </a:tc>
+                <a:tc>
+                  <a:txBody>
+                    <a:bodyPr/>
+                    <a:lstStyle/>
+                    <a:p>
+                      <a:pPr lvl="0" indent="0" marL="0">
+                        <a:buNone/>
+                      </a:pPr>
+                      <a:r>
+                        <a:rPr/>
+                        <a:t>P(T|T) 0,305 · [0,275; 0,340] · </a:t>
+                      </a:r>
+                      <a:r>
+                        <a:rPr b="1"/>
+                        <a:t>se rechaza H0</a:t>
+                      </a:r>
+                      <a:r>
+                        <a:rPr/>
+                        <a:t>, magnitud incierta</a:t>
+                      </a:r>
+                    </a:p>
+                  </a:txBody>
+                </a:tc>
+              </a:tr>
+            </a:tbl>
+          </a:graphicData>
+        </a:graphic>
+      </p:graphicFrame>
     </p:spTree>
   </p:cSld>
 </p:sld>

</xml_diff>

<commit_message>
docs: ronda 1 de la tarea 8 — presentación sin "autorización verificable" y KPI 1/2 con "validación con prototipo navegable"
- F1: en la lámina "4. Ética y regulación" el bullet de Habeas Data se alinea con 03_etica_legal.md §3.2 y validacion_stakeholder.md (participación voluntaria, sin datos personales ni nombre recogidos; el consentimiento verificable queda previsto para sesiones moderadas futuras). Regenerados presentacion.pdf (beamer) y presentacion.pptx; σ visible: pdftotext → 7.
- F2: en las filas "Cómo se mide" de KPI 1 y KPI 2 de 01_negocio.md §1.7, "sesión con el inversor" → "validación con prototipo navegable" (misma etiqueta que ya usa el resto del documento).
</commit_message>
<xml_diff>
--- a/entregables/entrega_1/presentacion.pptx
+++ b/entregables/entrega_1/presentacion.pptx
@@ -4472,7 +4472,17 @@
             </a:r>
             <a:r>
               <a:rPr/>
-              <a:t>: anonimización del participante y autorización verificable.</a:t>
+              <a:t>: en la validación asíncrona del 2026-10-18 el participante participó de forma voluntaria y no se recogieron datos personales ni su nombre; el guion prevé consentimiento previo e informado bajo código para las sesiones moderadas futuras (ver </a:t>
+            </a:r>
+            <a:r>
+              <a:rPr>
+                <a:latin typeface="Courier New"/>
+              </a:rPr>
+              <a:t>docs/entrega_1/03_etica_legal.md</a:t>
+            </a:r>
+            <a:r>
+              <a:rPr/>
+              <a:t> §3.2).</a:t>
             </a:r>
           </a:p>
           <a:p>

</xml_diff>